<commit_message>
Clean up free and pro product language
</commit_message>
<xml_diff>
--- a/public/templates/annual-planning-template.pptx
+++ b/public/templates/annual-planning-template.pptx
@@ -3980,7 +3980,7 @@
                 <a:ea typeface="Aptos" pitchFamily="34" charset="-122"/>
                 <a:cs typeface="Aptos" pitchFamily="34" charset="-120"/>
               </a:rPr>
-              <a:t>Editable chart placeholder</a:t>
+              <a:t>Editable chart area</a:t>
             </a:r>
             <a:endParaRPr lang="en-US" sz="1000" dirty="0"/>
           </a:p>
@@ -6149,7 +6149,7 @@
                 <a:ea typeface="Aptos" pitchFamily="34" charset="-122"/>
                 <a:cs typeface="Aptos" pitchFamily="34" charset="-120"/>
               </a:rPr>
-              <a:t>Editable chart placeholder</a:t>
+              <a:t>Editable chart area</a:t>
             </a:r>
             <a:endParaRPr lang="en-US" sz="1000" dirty="0"/>
           </a:p>
@@ -8318,7 +8318,7 @@
                 <a:ea typeface="Aptos" pitchFamily="34" charset="-122"/>
                 <a:cs typeface="Aptos" pitchFamily="34" charset="-120"/>
               </a:rPr>
-              <a:t>Editable chart placeholder</a:t>
+              <a:t>Editable chart area</a:t>
             </a:r>
             <a:endParaRPr lang="en-US" sz="1000" dirty="0"/>
           </a:p>
@@ -10487,7 +10487,7 @@
                 <a:ea typeface="Aptos" pitchFamily="34" charset="-122"/>
                 <a:cs typeface="Aptos" pitchFamily="34" charset="-120"/>
               </a:rPr>
-              <a:t>Editable chart placeholder</a:t>
+              <a:t>Editable chart area</a:t>
             </a:r>
             <a:endParaRPr lang="en-US" sz="1000" dirty="0"/>
           </a:p>
@@ -12656,7 +12656,7 @@
                 <a:ea typeface="Aptos" pitchFamily="34" charset="-122"/>
                 <a:cs typeface="Aptos" pitchFamily="34" charset="-120"/>
               </a:rPr>
-              <a:t>Editable chart placeholder</a:t>
+              <a:t>Editable chart area</a:t>
             </a:r>
             <a:endParaRPr lang="en-US" sz="1000" dirty="0"/>
           </a:p>
@@ -14825,7 +14825,7 @@
                 <a:ea typeface="Aptos" pitchFamily="34" charset="-122"/>
                 <a:cs typeface="Aptos" pitchFamily="34" charset="-120"/>
               </a:rPr>
-              <a:t>Editable chart placeholder</a:t>
+              <a:t>Editable chart area</a:t>
             </a:r>
             <a:endParaRPr lang="en-US" sz="1000" dirty="0"/>
           </a:p>

</xml_diff>

<commit_message>
Improve footer contrast and cleanup links
</commit_message>
<xml_diff>
--- a/public/templates/annual-planning-template.pptx
+++ b/public/templates/annual-planning-template.pptx
@@ -1436,7 +1436,7 @@
       </p:sp>
       <p:pic>
         <p:nvPicPr>
-          <p:cNvPr id="3" name="Image 0" descr="/Users/phylsion/Desktop/nam-tools/public/images/branding/logo-full.png">    </p:cNvPr>
+          <p:cNvPr id="3" name="Image 0" descr="APT logo">    </p:cNvPr>
           <p:cNvPicPr>
             <a:picLocks noChangeAspect="1"/>
           </p:cNvPicPr>
@@ -1602,7 +1602,7 @@
       </p:sp>
       <p:pic>
         <p:nvPicPr>
-          <p:cNvPr id="8" name="Image 1" descr="/Users/phylsion/Desktop/nam-tools/public/images/branding/logo-full.png">    </p:cNvPr>
+          <p:cNvPr id="8" name="Image 1" descr="APT logo">    </p:cNvPr>
           <p:cNvPicPr>
             <a:picLocks noChangeAspect="1"/>
           </p:cNvPicPr>
@@ -1754,7 +1754,7 @@
                 <a:ea typeface="Aptos" pitchFamily="34" charset="-122"/>
                 <a:cs typeface="Aptos" pitchFamily="34" charset="-120"/>
               </a:rPr>
-              <a:t>Prepared with editable fictional data for NAM and commercial planning.</a:t>
+              <a:t>Prepared with editable fictional data for account and commercial planning.</a:t>
             </a:r>
             <a:endParaRPr lang="en-US" sz="1300" dirty="0"/>
           </a:p>
@@ -2237,7 +2237,7 @@
       </p:sp>
       <p:pic>
         <p:nvPicPr>
-          <p:cNvPr id="3" name="Image 0" descr="/Users/phylsion/Desktop/nam-tools/public/images/branding/logo-full.png">    </p:cNvPr>
+          <p:cNvPr id="3" name="Image 0" descr="APT logo">    </p:cNvPr>
           <p:cNvPicPr>
             <a:picLocks noChangeAspect="1"/>
           </p:cNvPicPr>
@@ -4406,7 +4406,7 @@
       </p:sp>
       <p:pic>
         <p:nvPicPr>
-          <p:cNvPr id="3" name="Image 0" descr="/Users/phylsion/Desktop/nam-tools/public/images/branding/logo-full.png">    </p:cNvPr>
+          <p:cNvPr id="3" name="Image 0" descr="APT logo">    </p:cNvPr>
           <p:cNvPicPr>
             <a:picLocks noChangeAspect="1"/>
           </p:cNvPicPr>
@@ -6575,7 +6575,7 @@
       </p:sp>
       <p:pic>
         <p:nvPicPr>
-          <p:cNvPr id="3" name="Image 0" descr="/Users/phylsion/Desktop/nam-tools/public/images/branding/logo-full.png">    </p:cNvPr>
+          <p:cNvPr id="3" name="Image 0" descr="APT logo">    </p:cNvPr>
           <p:cNvPicPr>
             <a:picLocks noChangeAspect="1"/>
           </p:cNvPicPr>
@@ -8744,7 +8744,7 @@
       </p:sp>
       <p:pic>
         <p:nvPicPr>
-          <p:cNvPr id="3" name="Image 0" descr="/Users/phylsion/Desktop/nam-tools/public/images/branding/logo-full.png">    </p:cNvPr>
+          <p:cNvPr id="3" name="Image 0" descr="APT logo">    </p:cNvPr>
           <p:cNvPicPr>
             <a:picLocks noChangeAspect="1"/>
           </p:cNvPicPr>
@@ -10913,7 +10913,7 @@
       </p:sp>
       <p:pic>
         <p:nvPicPr>
-          <p:cNvPr id="3" name="Image 0" descr="/Users/phylsion/Desktop/nam-tools/public/images/branding/logo-full.png">    </p:cNvPr>
+          <p:cNvPr id="3" name="Image 0" descr="APT logo">    </p:cNvPr>
           <p:cNvPicPr>
             <a:picLocks noChangeAspect="1"/>
           </p:cNvPicPr>
@@ -13082,7 +13082,7 @@
       </p:sp>
       <p:pic>
         <p:nvPicPr>
-          <p:cNvPr id="3" name="Image 0" descr="/Users/phylsion/Desktop/nam-tools/public/images/branding/logo-full.png">    </p:cNvPr>
+          <p:cNvPr id="3" name="Image 0" descr="APT logo">    </p:cNvPr>
           <p:cNvPicPr>
             <a:picLocks noChangeAspect="1"/>
           </p:cNvPicPr>

</xml_diff>